<commit_message>
Point poster code link at the GitHub repo
The OSF project is private, so the printed link and QR would have 404d for
anyone at the poster session. OSF stays as the blinded artifact the paper
cites; its anonymous view-only link keeps working on a private project.

Co-Authored-By: Claude Opus 5 <noreply@anthropic.com>
</commit_message>
<xml_diff>
--- a/poster/FL_Poster_Chevuri_Aledhari.pptx
+++ b/poster/FL_Poster_Chevuri_Aledhari.pptx
@@ -4650,7 +4650,7 @@
                 <a:latin typeface="+mn-lt"/>
                 <a:ea typeface="Arial" panose="020B0604020202020204" pitchFamily="34" charset="0"/>
               </a:rPr>
-              <a:t>Code, data and the full experimental harness are open, with a script that re-checks every number on this poster.</a:t>
+              <a:t>Code, merged results and the full experimental harness are open, with a script that re-checks every number on this poster.</a:t>
             </a:r>
             <a:endParaRPr lang="en-US" sz="1400" dirty="0">
               <a:effectLst/>
@@ -4672,7 +4672,7 @@
               <a:buNone/>
             </a:pPr>
             <a:r>
-              <a:rPr lang="en-US" sz="2400" dirty="0" err="1">
+              <a:rPr lang="en-US" sz="2000" dirty="0" err="1">
                 <a:solidFill>
                   <a:schemeClr val="tx1"/>
                 </a:solidFill>
@@ -4680,7 +4680,7 @@
                 <a:latin typeface="+mn-lt"/>
                 <a:ea typeface="Arial" panose="020B0604020202020204" pitchFamily="34" charset="0"/>
               </a:rPr>
-              <a:t>osf.io/d5u2q</a:t>
+              <a:t>github.com/kunalchevuri/federated-learning-health-robustness</a:t>
             </a:r>
             <a:endParaRPr lang="en-US" sz="1400" dirty="0">
               <a:effectLst/>

</xml_diff>

<commit_message>
Match the example posters section flow more closely
Methods now runs off the bottom of column 1 and resumes as "Methods,
continued" at the top of column 2, the way the Chien example carries a long
section across a column break.

Dataset and Methods headers are descriptive rather than one-word labels,
matching "Dataset: The Nahant Time-Series" in the example.

References move bottom-left, where the Bylinskii example puts its paper and
dataset box, which also lets column 3 close on Acknowledgements exactly as
the Chien example does. Keeping a reference section at all is the one
deliberate departure: Chien cites inline and has no such section.

Co-Authored-By: Claude Opus 5 <noreply@anthropic.com>
</commit_message>
<xml_diff>
--- a/poster/FL_Poster_Chevuri_Aledhari.pptx
+++ b/poster/FL_Poster_Chevuri_Aledhari.pptx
@@ -3631,7 +3631,7 @@
                 </a:solidFill>
                 <a:latin typeface="Calibri"/>
               </a:rPr>
-              <a:t>Dataset</a:t>
+              <a:t>Dataset: two health datasets, split 20 ways</a:t>
             </a:r>
           </a:p>
         </p:txBody>
@@ -3838,7 +3838,7 @@
                 </a:solidFill>
                 <a:latin typeface="Calibri"/>
               </a:rPr>
-              <a:t>Code &amp; Data</a:t>
+              <a:t>Methods: seven merge rules and one control</a:t>
             </a:r>
           </a:p>
         </p:txBody>
@@ -3852,7 +3852,7 @@
         <p:spPr>
           <a:xfrm>
             <a:off x="548640" y="23348986"/>
-            <a:ext cx="4992624" cy="1806810"/>
+            <a:ext cx="6638544" cy="3522181"/>
           </a:xfrm>
           <a:prstGeom prst="rect">
             <a:avLst/>
@@ -3865,13 +3865,15 @@
           </a:bodyPr>
           <a:lstStyle/>
           <a:p>
-            <a:pPr>
+            <a:pPr indent="-215900" marL="215900">
               <a:spcBef>
                 <a:spcPts val="0"/>
               </a:spcBef>
               <a:spcAft>
                 <a:spcPts val="800"/>
               </a:spcAft>
+              <a:buFont typeface="Arial"/>
+              <a:buChar char="•"/>
             </a:pPr>
             <a:r>
               <a:rPr sz="1900">
@@ -3880,17 +3882,19 @@
                 </a:solidFill>
                 <a:latin typeface="Calibri"/>
               </a:rPr>
-              <a:t>All code, the merged results and a script that re-checks every number on this poster are openly available.</a:t>
-            </a:r>
-          </a:p>
-          <a:p>
-            <a:pPr>
+              <a:t>Seven merge rules run head to head: FedAvg, FedProx, CS-Agg, Krum, trimmed mean, coordinate-wise median, and an unweighted mean.</a:t>
+            </a:r>
+          </a:p>
+          <a:p>
+            <a:pPr indent="-215900" marL="215900">
               <a:spcBef>
                 <a:spcPts val="0"/>
               </a:spcBef>
               <a:spcAft>
                 <a:spcPts val="800"/>
               </a:spcAft>
+              <a:buFont typeface="Arial"/>
+              <a:buChar char="•"/>
             </a:pPr>
             <a:r>
               <a:rPr sz="1900">
@@ -3899,44 +3903,62 @@
                 </a:solidFill>
                 <a:latin typeface="Calibri"/>
               </a:rPr>
-              <a:t>github.com/kunalchevuri/federated-learning-health-robustness</a:t>
-            </a:r>
-          </a:p>
-        </p:txBody>
-      </p:sp>
-      <p:pic>
-        <p:nvPicPr>
-          <p:cNvPr id="28" name="Picture 27" descr="posterE_qr.png"/>
-          <p:cNvPicPr>
-            <a:picLocks noChangeAspect="1"/>
-          </p:cNvPicPr>
-          <p:nvPr/>
-        </p:nvPicPr>
-        <p:blipFill>
-          <a:blip r:embed="rId6"/>
-          <a:stretch>
-            <a:fillRect/>
-          </a:stretch>
-        </p:blipFill>
-        <p:spPr>
-          <a:xfrm>
-            <a:off x="5724144" y="23367274"/>
-            <a:ext cx="1417320" cy="1417320"/>
-          </a:xfrm>
-          <a:prstGeom prst="rect">
-            <a:avLst/>
-          </a:prstGeom>
-        </p:spPr>
-      </p:pic>
-      <p:sp>
-        <p:nvSpPr>
-          <p:cNvPr id="29" name="Rectangle 28"/>
+              <a:t>The unweighted mean is our control: it uses no robust statistic and differs from FedAvg only in ignoring how much data each site holds.</a:t>
+            </a:r>
+          </a:p>
+          <a:p>
+            <a:pPr indent="-215900" marL="215900">
+              <a:spcBef>
+                <a:spcPts val="0"/>
+              </a:spcBef>
+              <a:spcAft>
+                <a:spcPts val="800"/>
+              </a:spcAft>
+              <a:buFont typeface="Arial"/>
+              <a:buChar char="•"/>
+            </a:pPr>
+            <a:r>
+              <a:rPr sz="1900">
+                <a:solidFill>
+                  <a:srgbClr val="1A1A1A"/>
+                </a:solidFill>
+                <a:latin typeface="Calibri"/>
+              </a:rPr>
+              <a:t>Anything the control gains over FedAvg is therefore weighting alone, which is what isolates the effect.</a:t>
+            </a:r>
+          </a:p>
+          <a:p>
+            <a:pPr indent="-215900" marL="215900">
+              <a:spcBef>
+                <a:spcPts val="0"/>
+              </a:spcBef>
+              <a:spcAft>
+                <a:spcPts val="800"/>
+              </a:spcAft>
+              <a:buFont typeface="Arial"/>
+              <a:buChar char="•"/>
+            </a:pPr>
+            <a:r>
+              <a:rPr sz="1900">
+                <a:solidFill>
+                  <a:srgbClr val="1A1A1A"/>
+                </a:solidFill>
+                <a:latin typeface="Calibri"/>
+              </a:rPr>
+              <a:t>Labels are flipped at 20% of sites, across 0 to 30% of their records.</a:t>
+            </a:r>
+          </a:p>
+        </p:txBody>
+      </p:sp>
+      <p:sp>
+        <p:nvSpPr>
+          <p:cNvPr id="28" name="Rectangle 27"/>
           <p:cNvSpPr/>
           <p:nvPr/>
         </p:nvSpPr>
         <p:spPr>
           <a:xfrm>
-            <a:off x="548640" y="25338677"/>
+            <a:off x="548640" y="27054047"/>
             <a:ext cx="6638544" cy="713232"/>
           </a:xfrm>
           <a:prstGeom prst="rect">
@@ -3983,13 +4005,13 @@
       </p:sp>
       <p:sp>
         <p:nvSpPr>
-          <p:cNvPr id="30" name="TextBox 29"/>
+          <p:cNvPr id="29" name="TextBox 28"/>
           <p:cNvSpPr txBox="1"/>
           <p:nvPr/>
         </p:nvSpPr>
         <p:spPr>
           <a:xfrm>
-            <a:off x="548640" y="26161637"/>
+            <a:off x="548640" y="27877007"/>
             <a:ext cx="6638544" cy="3552661"/>
           </a:xfrm>
           <a:prstGeom prst="rect">
@@ -4120,7 +4142,7 @@
       </p:sp>
       <p:sp>
         <p:nvSpPr>
-          <p:cNvPr id="31" name="Rectangle 30"/>
+          <p:cNvPr id="30" name="Rectangle 29"/>
           <p:cNvSpPr/>
           <p:nvPr/>
         </p:nvSpPr>
@@ -4166,21 +4188,21 @@
                 </a:solidFill>
                 <a:latin typeface="Calibri"/>
               </a:rPr>
-              <a:t>Methods</a:t>
-            </a:r>
-          </a:p>
-        </p:txBody>
-      </p:sp>
-      <p:sp>
-        <p:nvSpPr>
-          <p:cNvPr id="32" name="TextBox 31"/>
+              <a:t>Methods, continued</a:t>
+            </a:r>
+          </a:p>
+        </p:txBody>
+      </p:sp>
+      <p:sp>
+        <p:nvSpPr>
+          <p:cNvPr id="31" name="TextBox 30"/>
           <p:cNvSpPr txBox="1"/>
           <p:nvPr/>
         </p:nvSpPr>
         <p:spPr>
           <a:xfrm>
             <a:off x="7644383" y="4133088"/>
-            <a:ext cx="6638544" cy="6365530"/>
+            <a:ext cx="6638544" cy="2934788"/>
           </a:xfrm>
           <a:prstGeom prst="rect">
             <a:avLst/>
@@ -4210,7 +4232,7 @@
                 </a:solidFill>
                 <a:latin typeface="Calibri"/>
               </a:rPr>
-              <a:t>Seven merge rules run head to head: FedAvg, FedProx, CS-Agg, Krum, trimmed mean, coordinate-wise median, and an unweighted mean.</a:t>
+              <a:t>On BRFSS we flip them only the way real people err, reporting no depression when they have it.</a:t>
             </a:r>
           </a:p>
           <a:p>
@@ -4231,7 +4253,7 @@
                 </a:solidFill>
                 <a:latin typeface="Calibri"/>
               </a:rPr>
-              <a:t>The unweighted mean is our control: it uses no robust statistic and differs from FedAvg only in ignoring how much data each site holds.</a:t>
+              <a:t>624 conditions cover every combination of rule, dataset, split, noise level and random seed.</a:t>
             </a:r>
           </a:p>
           <a:p>
@@ -4252,7 +4274,7 @@
                 </a:solidFill>
                 <a:latin typeface="Calibri"/>
               </a:rPr>
-              <a:t>Anything the control gains over FedAvg is therefore weighting alone, which is what isolates the effect.</a:t>
+              <a:t>Each runs 50 rounds, scored by AUC-ROC on a clean held-out test set the sites never see.</a:t>
             </a:r>
           </a:p>
           <a:p>
@@ -4273,90 +4295,6 @@
                 </a:solidFill>
                 <a:latin typeface="Calibri"/>
               </a:rPr>
-              <a:t>Labels are flipped at 20% of sites, across 0 to 30% of their records.</a:t>
-            </a:r>
-          </a:p>
-          <a:p>
-            <a:pPr indent="-215900" marL="215900">
-              <a:spcBef>
-                <a:spcPts val="0"/>
-              </a:spcBef>
-              <a:spcAft>
-                <a:spcPts val="800"/>
-              </a:spcAft>
-              <a:buFont typeface="Arial"/>
-              <a:buChar char="•"/>
-            </a:pPr>
-            <a:r>
-              <a:rPr sz="1900">
-                <a:solidFill>
-                  <a:srgbClr val="1A1A1A"/>
-                </a:solidFill>
-                <a:latin typeface="Calibri"/>
-              </a:rPr>
-              <a:t>On BRFSS we flip them only the way real people err, reporting no depression when they have it.</a:t>
-            </a:r>
-          </a:p>
-          <a:p>
-            <a:pPr indent="-215900" marL="215900">
-              <a:spcBef>
-                <a:spcPts val="0"/>
-              </a:spcBef>
-              <a:spcAft>
-                <a:spcPts val="800"/>
-              </a:spcAft>
-              <a:buFont typeface="Arial"/>
-              <a:buChar char="•"/>
-            </a:pPr>
-            <a:r>
-              <a:rPr sz="1900">
-                <a:solidFill>
-                  <a:srgbClr val="1A1A1A"/>
-                </a:solidFill>
-                <a:latin typeface="Calibri"/>
-              </a:rPr>
-              <a:t>624 conditions cover every combination of rule, dataset, split, noise level and random seed.</a:t>
-            </a:r>
-          </a:p>
-          <a:p>
-            <a:pPr indent="-215900" marL="215900">
-              <a:spcBef>
-                <a:spcPts val="0"/>
-              </a:spcBef>
-              <a:spcAft>
-                <a:spcPts val="800"/>
-              </a:spcAft>
-              <a:buFont typeface="Arial"/>
-              <a:buChar char="•"/>
-            </a:pPr>
-            <a:r>
-              <a:rPr sz="1900">
-                <a:solidFill>
-                  <a:srgbClr val="1A1A1A"/>
-                </a:solidFill>
-                <a:latin typeface="Calibri"/>
-              </a:rPr>
-              <a:t>Each runs 50 rounds, scored by AUC-ROC on a clean held-out test set the sites never see.</a:t>
-            </a:r>
-          </a:p>
-          <a:p>
-            <a:pPr indent="-215900" marL="215900">
-              <a:spcBef>
-                <a:spcPts val="0"/>
-              </a:spcBef>
-              <a:spcAft>
-                <a:spcPts val="800"/>
-              </a:spcAft>
-              <a:buFont typeface="Arial"/>
-              <a:buChar char="•"/>
-            </a:pPr>
-            <a:r>
-              <a:rPr sz="1900">
-                <a:solidFill>
-                  <a:srgbClr val="1A1A1A"/>
-                </a:solidFill>
-                <a:latin typeface="Calibri"/>
-              </a:rPr>
               <a:t>Differences are tested with Wilcoxon signed-rank, Holm-corrected within each of three comparison families.</a:t>
             </a:r>
           </a:p>
@@ -4364,13 +4302,13 @@
       </p:sp>
       <p:sp>
         <p:nvSpPr>
-          <p:cNvPr id="33" name="Rectangle 32"/>
+          <p:cNvPr id="32" name="Rectangle 31"/>
           <p:cNvSpPr/>
           <p:nvPr/>
         </p:nvSpPr>
         <p:spPr>
           <a:xfrm>
-            <a:off x="7644383" y="10681498"/>
+            <a:off x="7644383" y="7250756"/>
             <a:ext cx="6638544" cy="713232"/>
           </a:xfrm>
           <a:prstGeom prst="rect">
@@ -4417,13 +4355,13 @@
       </p:sp>
       <p:sp>
         <p:nvSpPr>
-          <p:cNvPr id="34" name="Rectangle 33"/>
+          <p:cNvPr id="33" name="Rectangle 32"/>
           <p:cNvSpPr/>
           <p:nvPr/>
         </p:nvSpPr>
         <p:spPr>
           <a:xfrm>
-            <a:off x="7644383" y="11504458"/>
+            <a:off x="7644383" y="8073716"/>
             <a:ext cx="6638544" cy="566928"/>
           </a:xfrm>
           <a:prstGeom prst="rect">
@@ -4470,21 +4408,21 @@
       </p:sp>
       <p:pic>
         <p:nvPicPr>
-          <p:cNvPr id="35" name="Picture 34" descr="posterA_decomposition.png"/>
+          <p:cNvPr id="34" name="Picture 33" descr="posterA_decomposition.png"/>
           <p:cNvPicPr>
             <a:picLocks noChangeAspect="1"/>
           </p:cNvPicPr>
           <p:nvPr/>
         </p:nvPicPr>
         <p:blipFill>
-          <a:blip r:embed="rId7"/>
+          <a:blip r:embed="rId6"/>
           <a:stretch>
             <a:fillRect/>
           </a:stretch>
         </p:blipFill>
         <p:spPr>
           <a:xfrm>
-            <a:off x="7644383" y="12181114"/>
+            <a:off x="7644383" y="8750372"/>
             <a:ext cx="6638544" cy="6766560"/>
           </a:xfrm>
           <a:prstGeom prst="rect">
@@ -4494,13 +4432,13 @@
       </p:pic>
       <p:sp>
         <p:nvSpPr>
-          <p:cNvPr id="36" name="TextBox 35"/>
+          <p:cNvPr id="35" name="TextBox 34"/>
           <p:cNvSpPr txBox="1"/>
           <p:nvPr/>
         </p:nvSpPr>
         <p:spPr>
           <a:xfrm>
-            <a:off x="7644383" y="19130554"/>
+            <a:off x="7644383" y="15699812"/>
             <a:ext cx="6638544" cy="2223951"/>
           </a:xfrm>
           <a:prstGeom prst="rect">
@@ -4580,13 +4518,13 @@
       </p:sp>
       <p:sp>
         <p:nvSpPr>
-          <p:cNvPr id="37" name="Rectangle 36"/>
+          <p:cNvPr id="36" name="Rectangle 35"/>
           <p:cNvSpPr/>
           <p:nvPr/>
         </p:nvSpPr>
         <p:spPr>
           <a:xfrm>
-            <a:off x="7644383" y="21537385"/>
+            <a:off x="7644383" y="18106643"/>
             <a:ext cx="6638544" cy="566928"/>
           </a:xfrm>
           <a:prstGeom prst="rect">
@@ -4633,21 +4571,21 @@
       </p:sp>
       <p:pic>
         <p:nvPicPr>
-          <p:cNvPr id="38" name="Picture 37" descr="posterC_runlevel.png"/>
+          <p:cNvPr id="37" name="Picture 36" descr="posterC_runlevel.png"/>
           <p:cNvPicPr>
             <a:picLocks noChangeAspect="1"/>
           </p:cNvPicPr>
           <p:nvPr/>
         </p:nvPicPr>
         <p:blipFill>
-          <a:blip r:embed="rId8"/>
+          <a:blip r:embed="rId7"/>
           <a:stretch>
             <a:fillRect/>
           </a:stretch>
         </p:blipFill>
         <p:spPr>
           <a:xfrm>
-            <a:off x="7644383" y="22214041"/>
+            <a:off x="7644383" y="18783299"/>
             <a:ext cx="6638544" cy="5669280"/>
           </a:xfrm>
           <a:prstGeom prst="rect">
@@ -4657,13 +4595,13 @@
       </p:pic>
       <p:sp>
         <p:nvSpPr>
-          <p:cNvPr id="39" name="TextBox 38"/>
+          <p:cNvPr id="38" name="TextBox 37"/>
           <p:cNvSpPr txBox="1"/>
           <p:nvPr/>
         </p:nvSpPr>
         <p:spPr>
           <a:xfrm>
-            <a:off x="7644383" y="28066201"/>
+            <a:off x="7644383" y="24635459"/>
             <a:ext cx="6638544" cy="802277"/>
           </a:xfrm>
           <a:prstGeom prst="rect">
@@ -4701,13 +4639,13 @@
       </p:sp>
       <p:sp>
         <p:nvSpPr>
-          <p:cNvPr id="40" name="Rectangle 39"/>
+          <p:cNvPr id="39" name="Rectangle 38"/>
           <p:cNvSpPr/>
           <p:nvPr/>
         </p:nvSpPr>
         <p:spPr>
           <a:xfrm>
-            <a:off x="14740128" y="3310128"/>
+            <a:off x="7644383" y="25620617"/>
             <a:ext cx="6638544" cy="713232"/>
           </a:xfrm>
           <a:prstGeom prst="rect">
@@ -4747,27 +4685,112 @@
                 </a:solidFill>
                 <a:latin typeface="Calibri"/>
               </a:rPr>
-              <a:t>Results, continued</a:t>
-            </a:r>
-          </a:p>
-        </p:txBody>
-      </p:sp>
-      <p:sp>
-        <p:nvSpPr>
-          <p:cNvPr id="41" name="Rectangle 40"/>
+              <a:t>Code &amp; Data</a:t>
+            </a:r>
+          </a:p>
+        </p:txBody>
+      </p:sp>
+      <p:sp>
+        <p:nvSpPr>
+          <p:cNvPr id="40" name="TextBox 39"/>
+          <p:cNvSpPr txBox="1"/>
+          <p:nvPr/>
+        </p:nvSpPr>
+        <p:spPr>
+          <a:xfrm>
+            <a:off x="7644383" y="26443577"/>
+            <a:ext cx="4992624" cy="1806810"/>
+          </a:xfrm>
+          <a:prstGeom prst="rect">
+            <a:avLst/>
+          </a:prstGeom>
+          <a:noFill/>
+        </p:spPr>
+        <p:txBody>
+          <a:bodyPr wrap="square" lIns="54864" rIns="0" tIns="0" bIns="0">
+            <a:spAutoFit/>
+          </a:bodyPr>
+          <a:lstStyle/>
+          <a:p>
+            <a:pPr>
+              <a:spcBef>
+                <a:spcPts val="0"/>
+              </a:spcBef>
+              <a:spcAft>
+                <a:spcPts val="800"/>
+              </a:spcAft>
+            </a:pPr>
+            <a:r>
+              <a:rPr sz="1900">
+                <a:solidFill>
+                  <a:srgbClr val="1A1A1A"/>
+                </a:solidFill>
+                <a:latin typeface="Calibri"/>
+              </a:rPr>
+              <a:t>All code, the merged results and a script that re-checks every number on this poster are openly available.</a:t>
+            </a:r>
+          </a:p>
+          <a:p>
+            <a:pPr>
+              <a:spcBef>
+                <a:spcPts val="0"/>
+              </a:spcBef>
+              <a:spcAft>
+                <a:spcPts val="800"/>
+              </a:spcAft>
+            </a:pPr>
+            <a:r>
+              <a:rPr sz="1900">
+                <a:solidFill>
+                  <a:srgbClr val="1A1A1A"/>
+                </a:solidFill>
+                <a:latin typeface="Calibri"/>
+              </a:rPr>
+              <a:t>github.com/kunalchevuri/federated-learning-health-robustness</a:t>
+            </a:r>
+          </a:p>
+        </p:txBody>
+      </p:sp>
+      <p:pic>
+        <p:nvPicPr>
+          <p:cNvPr id="41" name="Picture 40" descr="posterE_qr.png"/>
+          <p:cNvPicPr>
+            <a:picLocks noChangeAspect="1"/>
+          </p:cNvPicPr>
+          <p:nvPr/>
+        </p:nvPicPr>
+        <p:blipFill>
+          <a:blip r:embed="rId8"/>
+          <a:stretch>
+            <a:fillRect/>
+          </a:stretch>
+        </p:blipFill>
+        <p:spPr>
+          <a:xfrm>
+            <a:off x="12819888" y="26461865"/>
+            <a:ext cx="1417320" cy="1417320"/>
+          </a:xfrm>
+          <a:prstGeom prst="rect">
+            <a:avLst/>
+          </a:prstGeom>
+        </p:spPr>
+      </p:pic>
+      <p:sp>
+        <p:nvSpPr>
+          <p:cNvPr id="42" name="Rectangle 41"/>
           <p:cNvSpPr/>
           <p:nvPr/>
         </p:nvSpPr>
         <p:spPr>
           <a:xfrm>
-            <a:off x="14740128" y="4133088"/>
-            <a:ext cx="6638544" cy="566928"/>
+            <a:off x="14740128" y="3310128"/>
+            <a:ext cx="6638544" cy="713232"/>
           </a:xfrm>
           <a:prstGeom prst="rect">
             <a:avLst/>
           </a:prstGeom>
           <a:solidFill>
-            <a:srgbClr val="3F8C5C"/>
+            <a:srgbClr val="007439"/>
           </a:solidFill>
           <a:ln>
             <a:noFill/>
@@ -4794,115 +4817,26 @@
           <a:p>
             <a:pPr algn="l"/>
             <a:r>
-              <a:rPr sz="1900" b="1">
+              <a:rPr sz="2500" b="1">
                 <a:solidFill>
                   <a:srgbClr val="FFFFFF"/>
                 </a:solidFill>
                 <a:latin typeface="Calibri"/>
               </a:rPr>
-              <a:t>Lopsided data hurts far more than broken labels</a:t>
-            </a:r>
-          </a:p>
-        </p:txBody>
-      </p:sp>
-      <p:pic>
-        <p:nvPicPr>
-          <p:cNvPr id="42" name="Picture 41" descr="posterG_stressors.png"/>
-          <p:cNvPicPr>
-            <a:picLocks noChangeAspect="1"/>
-          </p:cNvPicPr>
-          <p:nvPr/>
-        </p:nvPicPr>
-        <p:blipFill>
-          <a:blip r:embed="rId9"/>
-          <a:stretch>
-            <a:fillRect/>
-          </a:stretch>
-        </p:blipFill>
-        <p:spPr>
-          <a:xfrm>
-            <a:off x="14740128" y="4809744"/>
-            <a:ext cx="6638544" cy="4023360"/>
-          </a:xfrm>
-          <a:prstGeom prst="rect">
-            <a:avLst/>
-          </a:prstGeom>
-        </p:spPr>
-      </p:pic>
-      <p:sp>
-        <p:nvSpPr>
-          <p:cNvPr id="43" name="TextBox 42"/>
-          <p:cNvSpPr txBox="1"/>
-          <p:nvPr/>
-        </p:nvSpPr>
-        <p:spPr>
-          <a:xfrm>
-            <a:off x="14740128" y="9015984"/>
-            <a:ext cx="6638544" cy="1513114"/>
-          </a:xfrm>
-          <a:prstGeom prst="rect">
-            <a:avLst/>
-          </a:prstGeom>
-          <a:noFill/>
-        </p:spPr>
-        <p:txBody>
-          <a:bodyPr wrap="square" lIns="54864" rIns="0" tIns="0" bIns="0">
-            <a:spAutoFit/>
-          </a:bodyPr>
-          <a:lstStyle/>
-          <a:p>
-            <a:pPr indent="-215900" marL="215900">
-              <a:spcBef>
-                <a:spcPts val="0"/>
-              </a:spcBef>
-              <a:spcAft>
-                <a:spcPts val="800"/>
-              </a:spcAft>
-              <a:buFont typeface="Arial"/>
-              <a:buChar char="•"/>
-            </a:pPr>
-            <a:r>
-              <a:rPr sz="1900">
-                <a:solidFill>
-                  <a:srgbClr val="1A1A1A"/>
-                </a:solidFill>
-                <a:latin typeface="Calibri"/>
-              </a:rPr>
-              <a:t>Moving from alpha = 1.0 to 0.1 costs FedAvg 0.2348 AUC, while 0% to 30% label noise costs it 0.0016.</a:t>
-            </a:r>
-          </a:p>
-          <a:p>
-            <a:pPr indent="-215900" marL="215900">
-              <a:spcBef>
-                <a:spcPts val="0"/>
-              </a:spcBef>
-              <a:spcAft>
-                <a:spcPts val="800"/>
-              </a:spcAft>
-              <a:buFont typeface="Arial"/>
-              <a:buChar char="•"/>
-            </a:pPr>
-            <a:r>
-              <a:rPr sz="1900">
-                <a:solidFill>
-                  <a:srgbClr val="1A1A1A"/>
-                </a:solidFill>
-                <a:latin typeface="Calibri"/>
-              </a:rPr>
-              <a:t>That 149x gap narrows to about 14x when sites track twelve health variables instead of four, but it never closes.</a:t>
-            </a:r>
-          </a:p>
-        </p:txBody>
-      </p:sp>
-      <p:sp>
-        <p:nvSpPr>
-          <p:cNvPr id="44" name="Rectangle 43"/>
+              <a:t>Results, continued</a:t>
+            </a:r>
+          </a:p>
+        </p:txBody>
+      </p:sp>
+      <p:sp>
+        <p:nvSpPr>
+          <p:cNvPr id="43" name="Rectangle 42"/>
           <p:cNvSpPr/>
           <p:nvPr/>
         </p:nvSpPr>
         <p:spPr>
           <a:xfrm>
-            <a:off x="14740128" y="10711978"/>
+            <a:off x="14740128" y="4133088"/>
             <a:ext cx="6638544" cy="566928"/>
           </a:xfrm>
           <a:prstGeom prst="rect">
@@ -4942,29 +4876,29 @@
                 </a:solidFill>
                 <a:latin typeface="Calibri"/>
               </a:rPr>
-              <a:t>A clean benchmark would have hidden all of this</a:t>
+              <a:t>Lopsided data hurts far more than broken labels</a:t>
             </a:r>
           </a:p>
         </p:txBody>
       </p:sp>
       <p:pic>
         <p:nvPicPr>
-          <p:cNvPr id="45" name="Picture 44" descr="posterB_both_datasets.png"/>
+          <p:cNvPr id="44" name="Picture 43" descr="posterG_stressors.png"/>
           <p:cNvPicPr>
             <a:picLocks noChangeAspect="1"/>
           </p:cNvPicPr>
           <p:nvPr/>
         </p:nvPicPr>
         <p:blipFill>
-          <a:blip r:embed="rId10"/>
+          <a:blip r:embed="rId9"/>
           <a:stretch>
             <a:fillRect/>
           </a:stretch>
         </p:blipFill>
         <p:spPr>
           <a:xfrm>
-            <a:off x="14740128" y="11388634"/>
-            <a:ext cx="6638544" cy="6583680"/>
+            <a:off x="14740128" y="4809744"/>
+            <a:ext cx="6638544" cy="3886200"/>
           </a:xfrm>
           <a:prstGeom prst="rect">
             <a:avLst/>
@@ -4973,13 +4907,13 @@
       </p:pic>
       <p:sp>
         <p:nvSpPr>
-          <p:cNvPr id="46" name="TextBox 45"/>
+          <p:cNvPr id="45" name="TextBox 44"/>
           <p:cNvSpPr txBox="1"/>
           <p:nvPr/>
         </p:nvSpPr>
         <p:spPr>
           <a:xfrm>
-            <a:off x="14740128" y="18155194"/>
+            <a:off x="14740128" y="8878824"/>
             <a:ext cx="6638544" cy="1513114"/>
           </a:xfrm>
           <a:prstGeom prst="rect">
@@ -5010,7 +4944,7 @@
                 </a:solidFill>
                 <a:latin typeface="Calibri"/>
               </a:rPr>
-              <a:t>On Breast Cancer every rule but Krum reaches 0.997 AUC or better, where no difference between them is visible.</a:t>
+              <a:t>Moving from alpha = 1.0 to 0.1 costs FedAvg 0.2348 AUC, while 0% to 30% label noise costs it 0.0016.</a:t>
             </a:r>
           </a:p>
           <a:p>
@@ -5031,27 +4965,27 @@
                 </a:solidFill>
                 <a:latin typeface="Calibri"/>
               </a:rPr>
-              <a:t>Messy, self-reported population health data is where these rules actually separate.</a:t>
-            </a:r>
-          </a:p>
-        </p:txBody>
-      </p:sp>
-      <p:sp>
-        <p:nvSpPr>
-          <p:cNvPr id="47" name="Rectangle 46"/>
+              <a:t>That 149x gap narrows to about 14x when sites track twelve health variables instead of four, but it never closes.</a:t>
+            </a:r>
+          </a:p>
+        </p:txBody>
+      </p:sp>
+      <p:sp>
+        <p:nvSpPr>
+          <p:cNvPr id="46" name="Rectangle 45"/>
           <p:cNvSpPr/>
           <p:nvPr/>
         </p:nvSpPr>
         <p:spPr>
           <a:xfrm>
-            <a:off x="14740128" y="19851188"/>
-            <a:ext cx="6638544" cy="713232"/>
+            <a:off x="14740128" y="10574818"/>
+            <a:ext cx="6638544" cy="566928"/>
           </a:xfrm>
           <a:prstGeom prst="rect">
             <a:avLst/>
           </a:prstGeom>
           <a:solidFill>
-            <a:srgbClr val="007439"/>
+            <a:srgbClr val="3F8C5C"/>
           </a:solidFill>
           <a:ln>
             <a:noFill/>
@@ -5078,17 +5012,41 @@
           <a:p>
             <a:pPr algn="l"/>
             <a:r>
-              <a:rPr sz="2500" b="1">
+              <a:rPr sz="1900" b="1">
                 <a:solidFill>
                   <a:srgbClr val="FFFFFF"/>
                 </a:solidFill>
                 <a:latin typeface="Calibri"/>
               </a:rPr>
-              <a:t>Future Directions</a:t>
-            </a:r>
-          </a:p>
-        </p:txBody>
-      </p:sp>
+              <a:t>A clean benchmark would have hidden all of this</a:t>
+            </a:r>
+          </a:p>
+        </p:txBody>
+      </p:sp>
+      <p:pic>
+        <p:nvPicPr>
+          <p:cNvPr id="47" name="Picture 46" descr="posterB_both_datasets.png"/>
+          <p:cNvPicPr>
+            <a:picLocks noChangeAspect="1"/>
+          </p:cNvPicPr>
+          <p:nvPr/>
+        </p:nvPicPr>
+        <p:blipFill>
+          <a:blip r:embed="rId10"/>
+          <a:stretch>
+            <a:fillRect/>
+          </a:stretch>
+        </p:blipFill>
+        <p:spPr>
+          <a:xfrm>
+            <a:off x="14740128" y="11251474"/>
+            <a:ext cx="6638544" cy="6217920"/>
+          </a:xfrm>
+          <a:prstGeom prst="rect">
+            <a:avLst/>
+          </a:prstGeom>
+        </p:spPr>
+      </p:pic>
       <p:sp>
         <p:nvSpPr>
           <p:cNvPr id="48" name="TextBox 47"/>
@@ -5097,8 +5055,8 @@
         </p:nvSpPr>
         <p:spPr>
           <a:xfrm>
-            <a:off x="14740128" y="20674148"/>
-            <a:ext cx="6638544" cy="2223951"/>
+            <a:off x="14740128" y="17652274"/>
+            <a:ext cx="6638544" cy="1513114"/>
           </a:xfrm>
           <a:prstGeom prst="rect">
             <a:avLst/>
@@ -5128,7 +5086,7 @@
                 </a:solidFill>
                 <a:latin typeface="Calibri"/>
               </a:rPr>
-              <a:t>Test adaptive Byzantine attackers, not only the label noise studied here.</a:t>
+              <a:t>On Breast Cancer every rule but Krum reaches 0.997 AUC or better, where no difference between them is visible.</a:t>
             </a:r>
           </a:p>
           <a:p>
@@ -5149,28 +5107,7 @@
                 </a:solidFill>
                 <a:latin typeface="Calibri"/>
               </a:rPr>
-              <a:t>Replace the simulated Dirichlet split with data partitioned across real institutions.</a:t>
-            </a:r>
-          </a:p>
-          <a:p>
-            <a:pPr indent="-215900" marL="215900">
-              <a:spcBef>
-                <a:spcPts val="0"/>
-              </a:spcBef>
-              <a:spcAft>
-                <a:spcPts val="800"/>
-              </a:spcAft>
-              <a:buFont typeface="Arial"/>
-              <a:buChar char="•"/>
-            </a:pPr>
-            <a:r>
-              <a:rPr sz="1900">
-                <a:solidFill>
-                  <a:srgbClr val="1A1A1A"/>
-                </a:solidFill>
-                <a:latin typeface="Calibri"/>
-              </a:rPr>
-              <a:t>Check whether the weighting effect persists for deeper models and larger numbers of sites.</a:t>
+              <a:t>Messy, self-reported population health data is where these rules actually separate.</a:t>
             </a:r>
           </a:p>
         </p:txBody>
@@ -5183,7 +5120,7 @@
         </p:nvSpPr>
         <p:spPr>
           <a:xfrm>
-            <a:off x="14740128" y="23080979"/>
+            <a:off x="14740128" y="19348268"/>
             <a:ext cx="6638544" cy="713232"/>
           </a:xfrm>
           <a:prstGeom prst="rect">
@@ -5223,7 +5160,7 @@
                 </a:solidFill>
                 <a:latin typeface="Calibri"/>
               </a:rPr>
-              <a:t>Conclusions</a:t>
+              <a:t>Future Directions</a:t>
             </a:r>
           </a:p>
         </p:txBody>
@@ -5236,8 +5173,8 @@
         </p:nvSpPr>
         <p:spPr>
           <a:xfrm>
-            <a:off x="14740128" y="23903940"/>
-            <a:ext cx="6638544" cy="3522181"/>
+            <a:off x="14740128" y="20171228"/>
+            <a:ext cx="6638544" cy="2223951"/>
           </a:xfrm>
           <a:prstGeom prst="rect">
             <a:avLst/>
@@ -5267,7 +5204,7 @@
                 </a:solidFill>
                 <a:latin typeface="Calibri"/>
               </a:rPr>
-              <a:t>Most of the advantage robust aggregators hold over FedAvg comes from how they weight sites, not from the robust statistic they are named for.</a:t>
+              <a:t>Test adaptive Byzantine attackers, not only the label noise studied here.</a:t>
             </a:r>
           </a:p>
           <a:p>
@@ -5288,7 +5225,7 @@
                 </a:solidFill>
                 <a:latin typeface="Calibri"/>
               </a:rPr>
-              <a:t>Any robustness evaluation run on size-skewed data should include an unweighted-mean control.</a:t>
+              <a:t>Replace the simulated Dirichlet split with data partitioned across real institutions.</a:t>
             </a:r>
           </a:p>
           <a:p>
@@ -5309,28 +5246,7 @@
                 </a:solidFill>
                 <a:latin typeface="Calibri"/>
               </a:rPr>
-              <a:t>The control costs one line of code, and without it a reported gain cannot be credited to robustness.</a:t>
-            </a:r>
-          </a:p>
-          <a:p>
-            <a:pPr indent="-215900" marL="215900">
-              <a:spcBef>
-                <a:spcPts val="0"/>
-              </a:spcBef>
-              <a:spcAft>
-                <a:spcPts val="800"/>
-              </a:spcAft>
-              <a:buFont typeface="Arial"/>
-              <a:buChar char="•"/>
-            </a:pPr>
-            <a:r>
-              <a:rPr sz="1900">
-                <a:solidFill>
-                  <a:srgbClr val="1A1A1A"/>
-                </a:solidFill>
-                <a:latin typeface="Calibri"/>
-              </a:rPr>
-              <a:t>A rule's reputation is not evidence: Krum is widely cited and failed here, while coordinate-wise median is simple and held.</a:t>
+              <a:t>Check whether the weighting effect persists for deeper models and larger numbers of sites.</a:t>
             </a:r>
           </a:p>
         </p:txBody>
@@ -5343,7 +5259,7 @@
         </p:nvSpPr>
         <p:spPr>
           <a:xfrm>
-            <a:off x="14740128" y="27609001"/>
+            <a:off x="14740128" y="22578060"/>
             <a:ext cx="6638544" cy="713232"/>
           </a:xfrm>
           <a:prstGeom prst="rect">
@@ -5383,7 +5299,7 @@
                 </a:solidFill>
                 <a:latin typeface="Calibri"/>
               </a:rPr>
-              <a:t>Acknowledgements</a:t>
+              <a:t>Conclusions</a:t>
             </a:r>
           </a:p>
         </p:txBody>
@@ -5396,7 +5312,167 @@
         </p:nvSpPr>
         <p:spPr>
           <a:xfrm>
-            <a:off x="14740128" y="28431961"/>
+            <a:off x="14740128" y="23401020"/>
+            <a:ext cx="6638544" cy="3522181"/>
+          </a:xfrm>
+          <a:prstGeom prst="rect">
+            <a:avLst/>
+          </a:prstGeom>
+          <a:noFill/>
+        </p:spPr>
+        <p:txBody>
+          <a:bodyPr wrap="square" lIns="54864" rIns="0" tIns="0" bIns="0">
+            <a:spAutoFit/>
+          </a:bodyPr>
+          <a:lstStyle/>
+          <a:p>
+            <a:pPr indent="-215900" marL="215900">
+              <a:spcBef>
+                <a:spcPts val="0"/>
+              </a:spcBef>
+              <a:spcAft>
+                <a:spcPts val="800"/>
+              </a:spcAft>
+              <a:buFont typeface="Arial"/>
+              <a:buChar char="•"/>
+            </a:pPr>
+            <a:r>
+              <a:rPr sz="1900">
+                <a:solidFill>
+                  <a:srgbClr val="1A1A1A"/>
+                </a:solidFill>
+                <a:latin typeface="Calibri"/>
+              </a:rPr>
+              <a:t>Most of the advantage robust aggregators hold over FedAvg comes from how they weight sites, not from the robust statistic they are named for.</a:t>
+            </a:r>
+          </a:p>
+          <a:p>
+            <a:pPr indent="-215900" marL="215900">
+              <a:spcBef>
+                <a:spcPts val="0"/>
+              </a:spcBef>
+              <a:spcAft>
+                <a:spcPts val="800"/>
+              </a:spcAft>
+              <a:buFont typeface="Arial"/>
+              <a:buChar char="•"/>
+            </a:pPr>
+            <a:r>
+              <a:rPr sz="1900">
+                <a:solidFill>
+                  <a:srgbClr val="1A1A1A"/>
+                </a:solidFill>
+                <a:latin typeface="Calibri"/>
+              </a:rPr>
+              <a:t>Any robustness evaluation run on size-skewed data should include an unweighted-mean control.</a:t>
+            </a:r>
+          </a:p>
+          <a:p>
+            <a:pPr indent="-215900" marL="215900">
+              <a:spcBef>
+                <a:spcPts val="0"/>
+              </a:spcBef>
+              <a:spcAft>
+                <a:spcPts val="800"/>
+              </a:spcAft>
+              <a:buFont typeface="Arial"/>
+              <a:buChar char="•"/>
+            </a:pPr>
+            <a:r>
+              <a:rPr sz="1900">
+                <a:solidFill>
+                  <a:srgbClr val="1A1A1A"/>
+                </a:solidFill>
+                <a:latin typeface="Calibri"/>
+              </a:rPr>
+              <a:t>The control costs one line of code, and without it a reported gain cannot be credited to robustness.</a:t>
+            </a:r>
+          </a:p>
+          <a:p>
+            <a:pPr indent="-215900" marL="215900">
+              <a:spcBef>
+                <a:spcPts val="0"/>
+              </a:spcBef>
+              <a:spcAft>
+                <a:spcPts val="800"/>
+              </a:spcAft>
+              <a:buFont typeface="Arial"/>
+              <a:buChar char="•"/>
+            </a:pPr>
+            <a:r>
+              <a:rPr sz="1900">
+                <a:solidFill>
+                  <a:srgbClr val="1A1A1A"/>
+                </a:solidFill>
+                <a:latin typeface="Calibri"/>
+              </a:rPr>
+              <a:t>A rule's reputation is not evidence: Krum is widely cited and failed here, while coordinate-wise median is simple and held.</a:t>
+            </a:r>
+          </a:p>
+        </p:txBody>
+      </p:sp>
+      <p:sp>
+        <p:nvSpPr>
+          <p:cNvPr id="53" name="Rectangle 52"/>
+          <p:cNvSpPr/>
+          <p:nvPr/>
+        </p:nvSpPr>
+        <p:spPr>
+          <a:xfrm>
+            <a:off x="14740128" y="27106081"/>
+            <a:ext cx="6638544" cy="713232"/>
+          </a:xfrm>
+          <a:prstGeom prst="rect">
+            <a:avLst/>
+          </a:prstGeom>
+          <a:solidFill>
+            <a:srgbClr val="007439"/>
+          </a:solidFill>
+          <a:ln>
+            <a:noFill/>
+          </a:ln>
+          <a:effectLst/>
+        </p:spPr>
+        <p:style>
+          <a:lnRef idx="1">
+            <a:schemeClr val="accent1"/>
+          </a:lnRef>
+          <a:fillRef idx="3">
+            <a:schemeClr val="accent1"/>
+          </a:fillRef>
+          <a:effectRef idx="2">
+            <a:schemeClr val="accent1"/>
+          </a:effectRef>
+          <a:fontRef idx="minor">
+            <a:schemeClr val="lt1"/>
+          </a:fontRef>
+        </p:style>
+        <p:txBody>
+          <a:bodyPr rtlCol="0" anchor="ctr" wrap="square" lIns="146304" rIns="146304" tIns="0" bIns="0"/>
+          <a:lstStyle/>
+          <a:p>
+            <a:pPr algn="l"/>
+            <a:r>
+              <a:rPr sz="2500" b="1">
+                <a:solidFill>
+                  <a:srgbClr val="FFFFFF"/>
+                </a:solidFill>
+                <a:latin typeface="Calibri"/>
+              </a:rPr>
+              <a:t>Acknowledgements</a:t>
+            </a:r>
+          </a:p>
+        </p:txBody>
+      </p:sp>
+      <p:sp>
+        <p:nvSpPr>
+          <p:cNvPr id="54" name="TextBox 53"/>
+          <p:cNvSpPr txBox="1"/>
+          <p:nvPr/>
+        </p:nvSpPr>
+        <p:spPr>
+          <a:xfrm>
+            <a:off x="14740128" y="27929041"/>
             <a:ext cx="6638544" cy="1513114"/>
           </a:xfrm>
           <a:prstGeom prst="rect">

</xml_diff>

<commit_message>
Add the UNT footer bar from the .docx template
The UNT COI template ships in two versions: the .docx closes with a green
footer bar and the .pptx does not. The poster is built on the .pptx, so it
was missing. The footer is cloned from the header rectangle so it carries the
template gradient rather than a colour we picked.

Content now stops at 34.2 in to clear it; one more Methods bullet moved to
column 2 to buy the room.

Co-Authored-By: Claude Opus 5 <noreply@anthropic.com>
</commit_message>
<xml_diff>
--- a/poster/FL_Poster_Chevuri_Aledhari.pptx
+++ b/poster/FL_Poster_Chevuri_Aledhari.pptx
@@ -3262,6 +3262,79 @@
       </p:sp>
       <p:sp>
         <p:nvSpPr>
+          <p:cNvPr id="16" name="Rectangle 15">
+            <a:extLst>
+              <a:ext uri="{FF2B5EF4-FFF2-40B4-BE49-F238E27FC236}">
+                <a16:creationId xmlns:a16="http://schemas.microsoft.com/office/drawing/2014/main" id="{D3DF3914-160B-4294-A01A-8CB9C6320C14}"/>
+              </a:ext>
+            </a:extLst>
+          </p:cNvPr>
+          <p:cNvSpPr/>
+          <p:nvPr/>
+        </p:nvSpPr>
+        <p:spPr>
+          <a:xfrm>
+            <a:off x="0" y="31455360"/>
+            <a:ext cx="21945600" cy="1463040"/>
+          </a:xfrm>
+          <a:prstGeom prst="rect">
+            <a:avLst/>
+          </a:prstGeom>
+          <a:gradFill flip="none" rotWithShape="1">
+            <a:gsLst>
+              <a:gs pos="0">
+                <a:srgbClr val="007C3F">
+                  <a:shade val="30000"/>
+                  <a:satMod val="115000"/>
+                </a:srgbClr>
+              </a:gs>
+              <a:gs pos="50000">
+                <a:srgbClr val="007C3F">
+                  <a:shade val="67500"/>
+                  <a:satMod val="115000"/>
+                </a:srgbClr>
+              </a:gs>
+              <a:gs pos="100000">
+                <a:srgbClr val="007C3F">
+                  <a:shade val="100000"/>
+                  <a:satMod val="115000"/>
+                </a:srgbClr>
+              </a:gs>
+            </a:gsLst>
+            <a:lin ang="2700000" scaled="1"/>
+            <a:tileRect/>
+          </a:gradFill>
+          <a:ln>
+            <a:noFill/>
+          </a:ln>
+        </p:spPr>
+        <p:style>
+          <a:lnRef idx="2">
+            <a:schemeClr val="accent1">
+              <a:shade val="50000"/>
+            </a:schemeClr>
+          </a:lnRef>
+          <a:fillRef idx="1">
+            <a:schemeClr val="accent1"/>
+          </a:fillRef>
+          <a:effectRef idx="0">
+            <a:schemeClr val="accent1"/>
+          </a:effectRef>
+          <a:fontRef idx="minor">
+            <a:schemeClr val="lt1"/>
+          </a:fontRef>
+        </p:style>
+        <p:txBody>
+          <a:bodyPr rtlCol="0" anchor="ctr"/>
+          <a:lstStyle/>
+          <a:p>
+            <a:pPr algn="ctr"/>
+            <a:endParaRPr lang="en-US" sz="15552" dirty="0"/>
+          </a:p>
+        </p:txBody>
+      </p:sp>
+      <p:sp>
+        <p:nvSpPr>
           <p:cNvPr id="17" name="Rectangle 16"/>
           <p:cNvSpPr/>
           <p:nvPr/>
@@ -3852,7 +3925,7 @@
         <p:spPr>
           <a:xfrm>
             <a:off x="548640" y="23348986"/>
-            <a:ext cx="6638544" cy="3522181"/>
+            <a:ext cx="6638544" cy="2811344"/>
           </a:xfrm>
           <a:prstGeom prst="rect">
             <a:avLst/>
@@ -3927,27 +4000,6 @@
               <a:t>Anything the control gains over FedAvg is therefore weighting alone, which is what isolates the effect.</a:t>
             </a:r>
           </a:p>
-          <a:p>
-            <a:pPr indent="-215900" marL="215900">
-              <a:spcBef>
-                <a:spcPts val="0"/>
-              </a:spcBef>
-              <a:spcAft>
-                <a:spcPts val="800"/>
-              </a:spcAft>
-              <a:buFont typeface="Arial"/>
-              <a:buChar char="•"/>
-            </a:pPr>
-            <a:r>
-              <a:rPr sz="1900">
-                <a:solidFill>
-                  <a:srgbClr val="1A1A1A"/>
-                </a:solidFill>
-                <a:latin typeface="Calibri"/>
-              </a:rPr>
-              <a:t>Labels are flipped at 20% of sites, across 0 to 30% of their records.</a:t>
-            </a:r>
-          </a:p>
         </p:txBody>
       </p:sp>
       <p:sp>
@@ -3958,7 +4010,7 @@
         </p:nvSpPr>
         <p:spPr>
           <a:xfrm>
-            <a:off x="548640" y="27054047"/>
+            <a:off x="548640" y="26343210"/>
             <a:ext cx="6638544" cy="713232"/>
           </a:xfrm>
           <a:prstGeom prst="rect">
@@ -4011,7 +4063,7 @@
         </p:nvSpPr>
         <p:spPr>
           <a:xfrm>
-            <a:off x="548640" y="27877007"/>
+            <a:off x="548640" y="27166170"/>
             <a:ext cx="6638544" cy="3552661"/>
           </a:xfrm>
           <a:prstGeom prst="rect">
@@ -4202,7 +4254,7 @@
         <p:spPr>
           <a:xfrm>
             <a:off x="7644383" y="4133088"/>
-            <a:ext cx="6638544" cy="2934788"/>
+            <a:ext cx="6638544" cy="3645625"/>
           </a:xfrm>
           <a:prstGeom prst="rect">
             <a:avLst/>
@@ -4232,7 +4284,7 @@
                 </a:solidFill>
                 <a:latin typeface="Calibri"/>
               </a:rPr>
-              <a:t>On BRFSS we flip them only the way real people err, reporting no depression when they have it.</a:t>
+              <a:t>Labels are flipped at 20% of sites, across 0 to 30% of their records.</a:t>
             </a:r>
           </a:p>
           <a:p>
@@ -4253,7 +4305,7 @@
                 </a:solidFill>
                 <a:latin typeface="Calibri"/>
               </a:rPr>
-              <a:t>624 conditions cover every combination of rule, dataset, split, noise level and random seed.</a:t>
+              <a:t>On BRFSS we flip them only the way real people err, reporting no depression when they have it.</a:t>
             </a:r>
           </a:p>
           <a:p>
@@ -4274,7 +4326,7 @@
                 </a:solidFill>
                 <a:latin typeface="Calibri"/>
               </a:rPr>
-              <a:t>Each runs 50 rounds, scored by AUC-ROC on a clean held-out test set the sites never see.</a:t>
+              <a:t>624 conditions cover every combination of rule, dataset, split, noise level and random seed.</a:t>
             </a:r>
           </a:p>
           <a:p>
@@ -4295,6 +4347,27 @@
                 </a:solidFill>
                 <a:latin typeface="Calibri"/>
               </a:rPr>
+              <a:t>Each runs 50 rounds, scored by AUC-ROC on a clean held-out test set the sites never see.</a:t>
+            </a:r>
+          </a:p>
+          <a:p>
+            <a:pPr indent="-215900" marL="215900">
+              <a:spcBef>
+                <a:spcPts val="0"/>
+              </a:spcBef>
+              <a:spcAft>
+                <a:spcPts val="800"/>
+              </a:spcAft>
+              <a:buFont typeface="Arial"/>
+              <a:buChar char="•"/>
+            </a:pPr>
+            <a:r>
+              <a:rPr sz="1900">
+                <a:solidFill>
+                  <a:srgbClr val="1A1A1A"/>
+                </a:solidFill>
+                <a:latin typeface="Calibri"/>
+              </a:rPr>
               <a:t>Differences are tested with Wilcoxon signed-rank, Holm-corrected within each of three comparison families.</a:t>
             </a:r>
           </a:p>
@@ -4308,7 +4381,7 @@
         </p:nvSpPr>
         <p:spPr>
           <a:xfrm>
-            <a:off x="7644383" y="7250756"/>
+            <a:off x="7644383" y="7961593"/>
             <a:ext cx="6638544" cy="713232"/>
           </a:xfrm>
           <a:prstGeom prst="rect">
@@ -4361,7 +4434,7 @@
         </p:nvSpPr>
         <p:spPr>
           <a:xfrm>
-            <a:off x="7644383" y="8073716"/>
+            <a:off x="7644383" y="8784553"/>
             <a:ext cx="6638544" cy="566928"/>
           </a:xfrm>
           <a:prstGeom prst="rect">
@@ -4422,7 +4495,7 @@
         </p:blipFill>
         <p:spPr>
           <a:xfrm>
-            <a:off x="7644383" y="8750372"/>
+            <a:off x="7644383" y="9461209"/>
             <a:ext cx="6638544" cy="6766560"/>
           </a:xfrm>
           <a:prstGeom prst="rect">
@@ -4438,7 +4511,7 @@
         </p:nvSpPr>
         <p:spPr>
           <a:xfrm>
-            <a:off x="7644383" y="15699812"/>
+            <a:off x="7644383" y="16410649"/>
             <a:ext cx="6638544" cy="2223951"/>
           </a:xfrm>
           <a:prstGeom prst="rect">
@@ -4524,7 +4597,7 @@
         </p:nvSpPr>
         <p:spPr>
           <a:xfrm>
-            <a:off x="7644383" y="18106643"/>
+            <a:off x="7644383" y="18817481"/>
             <a:ext cx="6638544" cy="566928"/>
           </a:xfrm>
           <a:prstGeom prst="rect">
@@ -4585,7 +4658,7 @@
         </p:blipFill>
         <p:spPr>
           <a:xfrm>
-            <a:off x="7644383" y="18783299"/>
+            <a:off x="7644383" y="19494137"/>
             <a:ext cx="6638544" cy="5669280"/>
           </a:xfrm>
           <a:prstGeom prst="rect">
@@ -4601,7 +4674,7 @@
         </p:nvSpPr>
         <p:spPr>
           <a:xfrm>
-            <a:off x="7644383" y="24635459"/>
+            <a:off x="7644383" y="25346297"/>
             <a:ext cx="6638544" cy="802277"/>
           </a:xfrm>
           <a:prstGeom prst="rect">
@@ -4645,7 +4718,7 @@
         </p:nvSpPr>
         <p:spPr>
           <a:xfrm>
-            <a:off x="7644383" y="25620617"/>
+            <a:off x="7644383" y="26331454"/>
             <a:ext cx="6638544" cy="713232"/>
           </a:xfrm>
           <a:prstGeom prst="rect">
@@ -4698,7 +4771,7 @@
         </p:nvSpPr>
         <p:spPr>
           <a:xfrm>
-            <a:off x="7644383" y="26443577"/>
+            <a:off x="7644383" y="27154414"/>
             <a:ext cx="4992624" cy="1806810"/>
           </a:xfrm>
           <a:prstGeom prst="rect">
@@ -4767,7 +4840,7 @@
         </p:blipFill>
         <p:spPr>
           <a:xfrm>
-            <a:off x="12819888" y="26461865"/>
+            <a:off x="12819888" y="27172702"/>
             <a:ext cx="1417320" cy="1417320"/>
           </a:xfrm>
           <a:prstGeom prst="rect">

</xml_diff>